<commit_message>
docs: update IETF 126 SCHC architecture side-meeting slides
</commit_message>
<xml_diff>
--- a/slides-side-meeting-2026-schc-architecture-1.pptx
+++ b/slides-side-meeting-2026-schc-architecture-1.pptx
@@ -20737,7 +20737,7 @@
         </p:spPr>
         <p:txBody>
           <a:bodyPr>
-            <a:normAutofit fontScale="85000" lnSpcReduction="10000"/>
+            <a:normAutofit fontScale="77500" lnSpcReduction="20000"/>
           </a:bodyPr>
           <a:lstStyle/>
           <a:p>
@@ -20764,25 +20764,17 @@
             </a:endParaRPr>
           </a:p>
           <a:p>
-            <a:pPr marL="114300" indent="0">
-              <a:buNone/>
+            <a:pPr>
+              <a:buFont typeface="Wingdings" pitchFamily="2" charset="2"/>
+              <a:buChar char="à"/>
             </a:pPr>
             <a:r>
               <a:rPr lang="en-US" dirty="0">
                 <a:solidFill>
                   <a:schemeClr val="bg2"/>
                 </a:solidFill>
-                <a:sym typeface="Wingdings" pitchFamily="2" charset="2"/>
               </a:rPr>
-              <a:t> </a:t>
-            </a:r>
-            <a:r>
-              <a:rPr lang="en-US" dirty="0">
-                <a:solidFill>
-                  <a:schemeClr val="bg2"/>
-                </a:solidFill>
-              </a:rPr>
-              <a:t>Automatically processed 7 RFCs and 17 drafts against -06 version (Claude, Gemini, Codex) </a:t>
+              <a:t>Automatically processed 7 RFCs and 17 drafts against -06 version (Claude, Gemini, meta-analysis with Codex) </a:t>
             </a:r>
           </a:p>
           <a:p>
@@ -20845,8 +20837,33 @@
                   <a:schemeClr val="bg2"/>
                 </a:solidFill>
               </a:rPr>
-              <a:t>An email will be sent to the draft authors with a +diff suggestion</a:t>
+              <a:t>With diff suggestions</a:t>
             </a:r>
+          </a:p>
+          <a:p>
+            <a:pPr lvl="1"/>
+            <a:r>
+              <a:rPr lang="en-US" dirty="0">
+                <a:solidFill>
+                  <a:schemeClr val="bg2"/>
+                </a:solidFill>
+                <a:hlinkClick r:id="rId2"/>
+              </a:rPr>
+              <a:t>https://github.com/lp-wan/archi/tree/main/archi-06-document-analysis</a:t>
+            </a:r>
+            <a:endParaRPr lang="en-US" dirty="0">
+              <a:solidFill>
+                <a:schemeClr val="bg2"/>
+              </a:solidFill>
+            </a:endParaRPr>
+          </a:p>
+          <a:p>
+            <a:pPr lvl="1"/>
+            <a:endParaRPr lang="en-US" dirty="0">
+              <a:solidFill>
+                <a:schemeClr val="bg2"/>
+              </a:solidFill>
+            </a:endParaRPr>
           </a:p>
           <a:p>
             <a:r>

</xml_diff>